<commit_message>
dcoumentos de metodologia algin
</commit_message>
<xml_diff>
--- a/Metodologia Scrum/Mapa de Actores SOC.pptx
+++ b/Metodologia Scrum/Mapa de Actores SOC.pptx
@@ -7,7 +7,7 @@
   <p:sldIdLst>
     <p:sldId id="256" r:id="rId2"/>
   </p:sldIdLst>
-  <p:sldSz cx="9144000" cy="6858000" type="screen4x3"/>
+  <p:sldSz cx="12192000" cy="6858000"/>
   <p:notesSz cx="6858000" cy="9144000"/>
   <p:defaultTextStyle>
     <a:defPPr>
@@ -107,12 +107,12 @@
   <p:extLst>
     <p:ext uri="{EFAFB233-063F-42B5-8137-9DF3F51BA10A}">
       <p15:sldGuideLst xmlns:p15="http://schemas.microsoft.com/office/powerpoint/2012/main">
-        <p15:guide id="1" orient="horz" pos="2160">
+        <p15:guide id="1" orient="horz" pos="2160" userDrawn="1">
           <p15:clr>
             <a:srgbClr val="A4A3A4"/>
           </p15:clr>
         </p15:guide>
-        <p15:guide id="2" pos="2880">
+        <p15:guide id="2" pos="3840" userDrawn="1">
           <p15:clr>
             <a:srgbClr val="A4A3A4"/>
           </p15:clr>
@@ -152,8 +152,8 @@
         </p:nvSpPr>
         <p:spPr>
           <a:xfrm>
-            <a:off x="685800" y="2130425"/>
-            <a:ext cx="7772400" cy="1470025"/>
+            <a:off x="914400" y="2130426"/>
+            <a:ext cx="10363200" cy="1470025"/>
           </a:xfrm>
         </p:spPr>
         <p:txBody>
@@ -179,8 +179,8 @@
         </p:nvSpPr>
         <p:spPr>
           <a:xfrm>
-            <a:off x="1371600" y="3886200"/>
-            <a:ext cx="6400800" cy="1752600"/>
+            <a:off x="1828800" y="3886200"/>
+            <a:ext cx="8534400" cy="1752600"/>
           </a:xfrm>
         </p:spPr>
         <p:txBody>
@@ -302,7 +302,7 @@
           <a:p>
             <a:fld id="{5BCAD085-E8A6-8845-BD4E-CB4CCA059FC4}" type="datetimeFigureOut">
               <a:rPr lang="en-US" smtClean="0"/>
-              <a:t>10/11/2025</a:t>
+              <a:t>10/12/2025</a:t>
             </a:fld>
             <a:endParaRPr lang="en-US"/>
           </a:p>
@@ -470,7 +470,7 @@
           <a:p>
             <a:fld id="{5BCAD085-E8A6-8845-BD4E-CB4CCA059FC4}" type="datetimeFigureOut">
               <a:rPr lang="en-US" smtClean="0"/>
-              <a:t>10/11/2025</a:t>
+              <a:t>10/12/2025</a:t>
             </a:fld>
             <a:endParaRPr lang="en-US"/>
           </a:p>
@@ -560,8 +560,8 @@
         </p:nvSpPr>
         <p:spPr>
           <a:xfrm>
-            <a:off x="6629400" y="274638"/>
-            <a:ext cx="2057400" cy="5851525"/>
+            <a:off x="8839200" y="274639"/>
+            <a:ext cx="2743200" cy="5851525"/>
           </a:xfrm>
         </p:spPr>
         <p:txBody>
@@ -587,8 +587,8 @@
         </p:nvSpPr>
         <p:spPr>
           <a:xfrm>
-            <a:off x="457200" y="274638"/>
-            <a:ext cx="6019800" cy="5851525"/>
+            <a:off x="609600" y="274639"/>
+            <a:ext cx="8026400" cy="5851525"/>
           </a:xfrm>
         </p:spPr>
         <p:txBody>
@@ -648,7 +648,7 @@
           <a:p>
             <a:fld id="{5BCAD085-E8A6-8845-BD4E-CB4CCA059FC4}" type="datetimeFigureOut">
               <a:rPr lang="en-US" smtClean="0"/>
-              <a:t>10/11/2025</a:t>
+              <a:t>10/12/2025</a:t>
             </a:fld>
             <a:endParaRPr lang="en-US"/>
           </a:p>
@@ -816,7 +816,7 @@
           <a:p>
             <a:fld id="{5BCAD085-E8A6-8845-BD4E-CB4CCA059FC4}" type="datetimeFigureOut">
               <a:rPr lang="en-US" smtClean="0"/>
-              <a:t>10/11/2025</a:t>
+              <a:t>10/12/2025</a:t>
             </a:fld>
             <a:endParaRPr lang="en-US"/>
           </a:p>
@@ -906,8 +906,8 @@
         </p:nvSpPr>
         <p:spPr>
           <a:xfrm>
-            <a:off x="722313" y="4406900"/>
-            <a:ext cx="7772400" cy="1362075"/>
+            <a:off x="963084" y="4406901"/>
+            <a:ext cx="10363200" cy="1362075"/>
           </a:xfrm>
         </p:spPr>
         <p:txBody>
@@ -937,8 +937,8 @@
         </p:nvSpPr>
         <p:spPr>
           <a:xfrm>
-            <a:off x="722313" y="2906713"/>
-            <a:ext cx="7772400" cy="1500187"/>
+            <a:off x="963084" y="2906713"/>
+            <a:ext cx="10363200" cy="1500187"/>
           </a:xfrm>
         </p:spPr>
         <p:txBody>
@@ -1061,7 +1061,7 @@
           <a:p>
             <a:fld id="{5BCAD085-E8A6-8845-BD4E-CB4CCA059FC4}" type="datetimeFigureOut">
               <a:rPr lang="en-US" smtClean="0"/>
-              <a:t>10/11/2025</a:t>
+              <a:t>10/12/2025</a:t>
             </a:fld>
             <a:endParaRPr lang="en-US"/>
           </a:p>
@@ -1173,8 +1173,8 @@
         </p:nvSpPr>
         <p:spPr>
           <a:xfrm>
-            <a:off x="457200" y="1600200"/>
-            <a:ext cx="4038600" cy="4525963"/>
+            <a:off x="609600" y="1600201"/>
+            <a:ext cx="5384800" cy="4525963"/>
           </a:xfrm>
         </p:spPr>
         <p:txBody>
@@ -1257,8 +1257,8 @@
         </p:nvSpPr>
         <p:spPr>
           <a:xfrm>
-            <a:off x="4648200" y="1600200"/>
-            <a:ext cx="4038600" cy="4525963"/>
+            <a:off x="6197600" y="1600201"/>
+            <a:ext cx="5384800" cy="4525963"/>
           </a:xfrm>
         </p:spPr>
         <p:txBody>
@@ -1346,7 +1346,7 @@
           <a:p>
             <a:fld id="{5BCAD085-E8A6-8845-BD4E-CB4CCA059FC4}" type="datetimeFigureOut">
               <a:rPr lang="en-US" smtClean="0"/>
-              <a:t>10/11/2025</a:t>
+              <a:t>10/12/2025</a:t>
             </a:fld>
             <a:endParaRPr lang="en-US"/>
           </a:p>
@@ -1462,8 +1462,8 @@
         </p:nvSpPr>
         <p:spPr>
           <a:xfrm>
-            <a:off x="457200" y="1535113"/>
-            <a:ext cx="4040188" cy="639762"/>
+            <a:off x="609600" y="1535113"/>
+            <a:ext cx="5386917" cy="639762"/>
           </a:xfrm>
         </p:spPr>
         <p:txBody>
@@ -1527,8 +1527,8 @@
         </p:nvSpPr>
         <p:spPr>
           <a:xfrm>
-            <a:off x="457200" y="2174875"/>
-            <a:ext cx="4040188" cy="3951288"/>
+            <a:off x="609600" y="2174875"/>
+            <a:ext cx="5386917" cy="3951288"/>
           </a:xfrm>
         </p:spPr>
         <p:txBody>
@@ -1611,8 +1611,8 @@
         </p:nvSpPr>
         <p:spPr>
           <a:xfrm>
-            <a:off x="4645025" y="1535113"/>
-            <a:ext cx="4041775" cy="639762"/>
+            <a:off x="6193368" y="1535113"/>
+            <a:ext cx="5389033" cy="639762"/>
           </a:xfrm>
         </p:spPr>
         <p:txBody>
@@ -1676,8 +1676,8 @@
         </p:nvSpPr>
         <p:spPr>
           <a:xfrm>
-            <a:off x="4645025" y="2174875"/>
-            <a:ext cx="4041775" cy="3951288"/>
+            <a:off x="6193368" y="2174875"/>
+            <a:ext cx="5389033" cy="3951288"/>
           </a:xfrm>
         </p:spPr>
         <p:txBody>
@@ -1765,7 +1765,7 @@
           <a:p>
             <a:fld id="{5BCAD085-E8A6-8845-BD4E-CB4CCA059FC4}" type="datetimeFigureOut">
               <a:rPr lang="en-US" smtClean="0"/>
-              <a:t>10/11/2025</a:t>
+              <a:t>10/12/2025</a:t>
             </a:fld>
             <a:endParaRPr lang="en-US"/>
           </a:p>
@@ -1882,7 +1882,7 @@
           <a:p>
             <a:fld id="{5BCAD085-E8A6-8845-BD4E-CB4CCA059FC4}" type="datetimeFigureOut">
               <a:rPr lang="en-US" smtClean="0"/>
-              <a:t>10/11/2025</a:t>
+              <a:t>10/12/2025</a:t>
             </a:fld>
             <a:endParaRPr lang="en-US"/>
           </a:p>
@@ -1977,7 +1977,7 @@
           <a:p>
             <a:fld id="{5BCAD085-E8A6-8845-BD4E-CB4CCA059FC4}" type="datetimeFigureOut">
               <a:rPr lang="en-US" smtClean="0"/>
-              <a:t>10/11/2025</a:t>
+              <a:t>10/12/2025</a:t>
             </a:fld>
             <a:endParaRPr lang="en-US"/>
           </a:p>
@@ -2067,8 +2067,8 @@
         </p:nvSpPr>
         <p:spPr>
           <a:xfrm>
-            <a:off x="457200" y="273050"/>
-            <a:ext cx="3008313" cy="1162050"/>
+            <a:off x="609601" y="273050"/>
+            <a:ext cx="4011084" cy="1162050"/>
           </a:xfrm>
         </p:spPr>
         <p:txBody>
@@ -2098,8 +2098,8 @@
         </p:nvSpPr>
         <p:spPr>
           <a:xfrm>
-            <a:off x="3575050" y="273050"/>
-            <a:ext cx="5111750" cy="5853113"/>
+            <a:off x="4766733" y="273051"/>
+            <a:ext cx="6815667" cy="5853113"/>
           </a:xfrm>
         </p:spPr>
         <p:txBody>
@@ -2182,8 +2182,8 @@
         </p:nvSpPr>
         <p:spPr>
           <a:xfrm>
-            <a:off x="457200" y="1435100"/>
-            <a:ext cx="3008313" cy="4691063"/>
+            <a:off x="609601" y="1435101"/>
+            <a:ext cx="4011084" cy="4691063"/>
           </a:xfrm>
         </p:spPr>
         <p:txBody>
@@ -2252,7 +2252,7 @@
           <a:p>
             <a:fld id="{5BCAD085-E8A6-8845-BD4E-CB4CCA059FC4}" type="datetimeFigureOut">
               <a:rPr lang="en-US" smtClean="0"/>
-              <a:t>10/11/2025</a:t>
+              <a:t>10/12/2025</a:t>
             </a:fld>
             <a:endParaRPr lang="en-US"/>
           </a:p>
@@ -2342,8 +2342,8 @@
         </p:nvSpPr>
         <p:spPr>
           <a:xfrm>
-            <a:off x="1792288" y="4800600"/>
-            <a:ext cx="5486400" cy="566738"/>
+            <a:off x="2389717" y="4800600"/>
+            <a:ext cx="7315200" cy="566738"/>
           </a:xfrm>
         </p:spPr>
         <p:txBody>
@@ -2373,8 +2373,8 @@
         </p:nvSpPr>
         <p:spPr>
           <a:xfrm>
-            <a:off x="1792288" y="612775"/>
-            <a:ext cx="5486400" cy="4114800"/>
+            <a:off x="2389717" y="612775"/>
+            <a:ext cx="7315200" cy="4114800"/>
           </a:xfrm>
         </p:spPr>
         <p:txBody>
@@ -2434,8 +2434,8 @@
         </p:nvSpPr>
         <p:spPr>
           <a:xfrm>
-            <a:off x="1792288" y="5367338"/>
-            <a:ext cx="5486400" cy="804862"/>
+            <a:off x="2389717" y="5367338"/>
+            <a:ext cx="7315200" cy="804862"/>
           </a:xfrm>
         </p:spPr>
         <p:txBody>
@@ -2504,7 +2504,7 @@
           <a:p>
             <a:fld id="{5BCAD085-E8A6-8845-BD4E-CB4CCA059FC4}" type="datetimeFigureOut">
               <a:rPr lang="en-US" smtClean="0"/>
-              <a:t>10/11/2025</a:t>
+              <a:t>10/12/2025</a:t>
             </a:fld>
             <a:endParaRPr lang="en-US"/>
           </a:p>
@@ -2599,8 +2599,8 @@
         </p:nvSpPr>
         <p:spPr>
           <a:xfrm>
-            <a:off x="457200" y="274638"/>
-            <a:ext cx="8229600" cy="1143000"/>
+            <a:off x="609600" y="274638"/>
+            <a:ext cx="10972800" cy="1143000"/>
           </a:xfrm>
           <a:prstGeom prst="rect">
             <a:avLst/>
@@ -2631,8 +2631,8 @@
         </p:nvSpPr>
         <p:spPr>
           <a:xfrm>
-            <a:off x="457200" y="1600200"/>
-            <a:ext cx="8229600" cy="4525963"/>
+            <a:off x="609600" y="1600201"/>
+            <a:ext cx="10972800" cy="4525963"/>
           </a:xfrm>
           <a:prstGeom prst="rect">
             <a:avLst/>
@@ -2692,8 +2692,8 @@
         </p:nvSpPr>
         <p:spPr>
           <a:xfrm>
-            <a:off x="457200" y="6356350"/>
-            <a:ext cx="2133600" cy="365125"/>
+            <a:off x="609600" y="6356351"/>
+            <a:ext cx="2844800" cy="365125"/>
           </a:xfrm>
           <a:prstGeom prst="rect">
             <a:avLst/>
@@ -2715,7 +2715,7 @@
           <a:p>
             <a:fld id="{5BCAD085-E8A6-8845-BD4E-CB4CCA059FC4}" type="datetimeFigureOut">
               <a:rPr lang="en-US" smtClean="0"/>
-              <a:t>10/11/2025</a:t>
+              <a:t>10/12/2025</a:t>
             </a:fld>
             <a:endParaRPr lang="en-US"/>
           </a:p>
@@ -2733,8 +2733,8 @@
         </p:nvSpPr>
         <p:spPr>
           <a:xfrm>
-            <a:off x="3124200" y="6356350"/>
-            <a:ext cx="2895600" cy="365125"/>
+            <a:off x="4165600" y="6356351"/>
+            <a:ext cx="3860800" cy="365125"/>
           </a:xfrm>
           <a:prstGeom prst="rect">
             <a:avLst/>
@@ -2770,8 +2770,8 @@
         </p:nvSpPr>
         <p:spPr>
           <a:xfrm>
-            <a:off x="6553200" y="6356350"/>
-            <a:ext cx="2133600" cy="365125"/>
+            <a:off x="8737600" y="6356351"/>
+            <a:ext cx="2844800" cy="365125"/>
           </a:xfrm>
           <a:prstGeom prst="rect">
             <a:avLst/>
@@ -3098,7 +3098,7 @@
         </p:nvSpPr>
         <p:spPr>
           <a:xfrm>
-            <a:off x="640080" y="274320"/>
+            <a:off x="2164081" y="274320"/>
             <a:ext cx="4960845" cy="523220"/>
           </a:xfrm>
           <a:prstGeom prst="rect">
@@ -3113,15 +3113,15 @@
           <a:lstStyle/>
           <a:p>
             <a:r>
-              <a:rPr sz="2800" b="1" dirty="0"/>
+              <a:rPr sz="2800" b="1" u="sng" dirty="0"/>
               <a:t>Mapa de </a:t>
             </a:r>
             <a:r>
-              <a:rPr sz="2800" b="1" dirty="0" err="1"/>
+              <a:rPr sz="2800" b="1" u="sng" dirty="0" err="1"/>
               <a:t>Actores</a:t>
             </a:r>
             <a:r>
-              <a:rPr sz="2800" b="1" dirty="0"/>
+              <a:rPr sz="2800" b="1" u="sng" dirty="0"/>
               <a:t>  Proyecto SOC </a:t>
             </a:r>
           </a:p>
@@ -3135,7 +3135,7 @@
         </p:nvSpPr>
         <p:spPr>
           <a:xfrm>
-            <a:off x="3120502" y="2468880"/>
+            <a:off x="4644502" y="2468880"/>
             <a:ext cx="2261220" cy="914400"/>
           </a:xfrm>
           <a:prstGeom prst="roundRect">
@@ -3187,22 +3187,22 @@
               </a:defRPr>
             </a:pPr>
             <a:r>
-              <a:rPr dirty="0"/>
+              <a:rPr sz="1600" dirty="0"/>
               <a:t>Sistema </a:t>
             </a:r>
             <a:r>
-              <a:rPr dirty="0" err="1"/>
+              <a:rPr sz="1600" dirty="0" err="1"/>
               <a:t>Operativo</a:t>
             </a:r>
             <a:r>
-              <a:rPr dirty="0"/>
+              <a:rPr sz="1600" dirty="0"/>
               <a:t> de </a:t>
             </a:r>
             <a:r>
-              <a:rPr dirty="0" err="1"/>
+              <a:rPr sz="1600" dirty="0" err="1"/>
               <a:t>Condominios</a:t>
             </a:r>
-            <a:endParaRPr dirty="0"/>
+            <a:endParaRPr sz="1600" dirty="0"/>
           </a:p>
         </p:txBody>
       </p:sp>
@@ -3214,7 +3214,7 @@
         </p:nvSpPr>
         <p:spPr>
           <a:xfrm>
-            <a:off x="0" y="822960"/>
+            <a:off x="1524000" y="822960"/>
             <a:ext cx="2354580" cy="1188720"/>
           </a:xfrm>
           <a:prstGeom prst="ellipse">
@@ -3303,7 +3303,7 @@
         </p:nvCxnSpPr>
         <p:spPr>
           <a:xfrm flipH="1" flipV="1">
-            <a:off x="2009760" y="1837596"/>
+            <a:off x="3533760" y="1837596"/>
             <a:ext cx="1110742" cy="1088484"/>
           </a:xfrm>
           <a:prstGeom prst="line">
@@ -3338,7 +3338,7 @@
         </p:nvSpPr>
         <p:spPr>
           <a:xfrm>
-            <a:off x="68580" y="2240280"/>
+            <a:off x="1592580" y="2240280"/>
             <a:ext cx="2286000" cy="1005840"/>
           </a:xfrm>
           <a:prstGeom prst="diamond">
@@ -3418,7 +3418,7 @@
         </p:nvCxnSpPr>
         <p:spPr>
           <a:xfrm flipH="1" flipV="1">
-            <a:off x="2354580" y="2743200"/>
+            <a:off x="3878580" y="2743200"/>
             <a:ext cx="765922" cy="182880"/>
           </a:xfrm>
           <a:prstGeom prst="line">
@@ -3453,7 +3453,7 @@
         </p:nvSpPr>
         <p:spPr>
           <a:xfrm>
-            <a:off x="11542" y="3474720"/>
+            <a:off x="1535542" y="3474720"/>
             <a:ext cx="2286000" cy="1005840"/>
           </a:xfrm>
           <a:prstGeom prst="parallelogram">
@@ -3538,7 +3538,7 @@
         </p:nvCxnSpPr>
         <p:spPr>
           <a:xfrm flipH="1">
-            <a:off x="2171812" y="2926080"/>
+            <a:off x="3695812" y="2926080"/>
             <a:ext cx="948690" cy="1051560"/>
           </a:xfrm>
           <a:prstGeom prst="line">
@@ -3573,7 +3573,7 @@
         </p:nvSpPr>
         <p:spPr>
           <a:xfrm>
-            <a:off x="1073148" y="4697307"/>
+            <a:off x="2597148" y="4697307"/>
             <a:ext cx="2286000" cy="1371600"/>
           </a:xfrm>
           <a:prstGeom prst="hexagon">
@@ -3658,7 +3658,7 @@
         </p:nvCxnSpPr>
         <p:spPr>
           <a:xfrm flipH="1">
-            <a:off x="3016248" y="3383280"/>
+            <a:off x="4540248" y="3383281"/>
             <a:ext cx="1234864" cy="1314027"/>
           </a:xfrm>
           <a:prstGeom prst="line">
@@ -3693,7 +3693,7 @@
         </p:nvSpPr>
         <p:spPr>
           <a:xfrm>
-            <a:off x="4312183" y="4749800"/>
+            <a:off x="5836183" y="4749800"/>
             <a:ext cx="1665182" cy="1371600"/>
           </a:xfrm>
           <a:prstGeom prst="bevel">
@@ -3794,7 +3794,7 @@
         </p:nvCxnSpPr>
         <p:spPr>
           <a:xfrm>
-            <a:off x="4251112" y="3383280"/>
+            <a:off x="5775112" y="3383280"/>
             <a:ext cx="893662" cy="1366520"/>
           </a:xfrm>
           <a:prstGeom prst="line">
@@ -3829,7 +3829,7 @@
         </p:nvSpPr>
         <p:spPr>
           <a:xfrm>
-            <a:off x="6582408" y="4589780"/>
+            <a:off x="8106409" y="4589780"/>
             <a:ext cx="2000039" cy="1280160"/>
           </a:xfrm>
           <a:prstGeom prst="trapezoid">
@@ -3917,7 +3917,7 @@
         </p:nvCxnSpPr>
         <p:spPr>
           <a:xfrm>
-            <a:off x="4251112" y="3383280"/>
+            <a:off x="5775112" y="3383280"/>
             <a:ext cx="3331316" cy="1206500"/>
           </a:xfrm>
           <a:prstGeom prst="line">
@@ -3952,7 +3952,7 @@
         </p:nvSpPr>
         <p:spPr>
           <a:xfrm>
-            <a:off x="6075861" y="2125980"/>
+            <a:off x="7599861" y="2125980"/>
             <a:ext cx="2926080" cy="1280160"/>
           </a:xfrm>
           <a:prstGeom prst="cloud">
@@ -3987,7 +3987,7 @@
           <a:p>
             <a:pPr algn="ctr"/>
             <a:r>
-              <a:rPr sz="1800" b="1" dirty="0" err="1">
+              <a:rPr b="1" dirty="0" err="1">
                 <a:solidFill>
                   <a:srgbClr val="FFFFFF"/>
                 </a:solidFill>
@@ -3995,7 +3995,7 @@
               <a:t>Residente</a:t>
             </a:r>
             <a:r>
-              <a:rPr sz="1800" b="1" dirty="0">
+              <a:rPr b="1" dirty="0">
                 <a:solidFill>
                   <a:srgbClr val="FFFFFF"/>
                 </a:solidFill>
@@ -4003,14 +4003,14 @@
               <a:t> / </a:t>
             </a:r>
             <a:r>
-              <a:rPr sz="1800" b="1" dirty="0" err="1">
+              <a:rPr b="1" dirty="0" err="1">
                 <a:solidFill>
                   <a:srgbClr val="FFFFFF"/>
                 </a:solidFill>
               </a:rPr>
               <a:t>Propietario</a:t>
             </a:r>
-            <a:endParaRPr sz="1800" b="1" dirty="0">
+            <a:endParaRPr b="1" dirty="0">
               <a:solidFill>
                 <a:srgbClr val="FFFFFF"/>
               </a:solidFill>
@@ -4025,29 +4025,29 @@
               </a:defRPr>
             </a:pPr>
             <a:r>
-              <a:rPr dirty="0"/>
+              <a:rPr sz="1200" dirty="0"/>
               <a:t>Pagos y </a:t>
             </a:r>
             <a:r>
-              <a:rPr dirty="0" err="1"/>
+              <a:rPr sz="1200" dirty="0" err="1"/>
               <a:t>reservas</a:t>
             </a:r>
             <a:br>
-              <a:rPr dirty="0"/>
+              <a:rPr sz="1200" dirty="0"/>
             </a:br>
             <a:r>
-              <a:rPr dirty="0" err="1"/>
+              <a:rPr sz="1200" dirty="0" err="1"/>
               <a:t>Recepción</a:t>
             </a:r>
             <a:r>
-              <a:rPr dirty="0"/>
+              <a:rPr sz="1200" dirty="0"/>
               <a:t> de </a:t>
             </a:r>
             <a:r>
-              <a:rPr dirty="0" err="1"/>
+              <a:rPr sz="1200" dirty="0" err="1"/>
               <a:t>avisos</a:t>
             </a:r>
-            <a:endParaRPr dirty="0"/>
+            <a:endParaRPr sz="1200" dirty="0"/>
           </a:p>
         </p:txBody>
       </p:sp>
@@ -4063,7 +4063,7 @@
         </p:nvCxnSpPr>
         <p:spPr>
           <a:xfrm flipV="1">
-            <a:off x="5381722" y="2766060"/>
+            <a:off x="6905723" y="2766060"/>
             <a:ext cx="703215" cy="160020"/>
           </a:xfrm>
           <a:prstGeom prst="line">
@@ -4098,7 +4098,7 @@
         </p:nvSpPr>
         <p:spPr>
           <a:xfrm>
-            <a:off x="6033345" y="617220"/>
+            <a:off x="7557345" y="617220"/>
             <a:ext cx="2568788" cy="1280160"/>
           </a:xfrm>
           <a:prstGeom prst="octagon">
@@ -4133,7 +4133,7 @@
           <a:p>
             <a:pPr algn="ctr"/>
             <a:r>
-              <a:rPr sz="1800" b="1">
+              <a:rPr b="1">
                 <a:solidFill>
                   <a:srgbClr val="FFFFFF"/>
                 </a:solidFill>
@@ -4150,10 +4150,14 @@
               </a:defRPr>
             </a:pPr>
             <a:r>
+              <a:rPr sz="1200"/>
               <a:t>Pagos / Mensajería</a:t>
             </a:r>
-            <a:br/>
-            <a:r>
+            <a:br>
+              <a:rPr sz="1200"/>
+            </a:br>
+            <a:r>
+              <a:rPr sz="1200"/>
               <a:t>Correo / Notificaciones</a:t>
             </a:r>
           </a:p>
@@ -4171,7 +4175,7 @@
         </p:nvCxnSpPr>
         <p:spPr>
           <a:xfrm flipV="1">
-            <a:off x="4251112" y="1897380"/>
+            <a:off x="5775113" y="1897380"/>
             <a:ext cx="2157179" cy="571500"/>
           </a:xfrm>
           <a:prstGeom prst="line">
@@ -4206,7 +4210,7 @@
         </p:nvSpPr>
         <p:spPr>
           <a:xfrm>
-            <a:off x="2904180" y="877476"/>
+            <a:off x="4428180" y="877476"/>
             <a:ext cx="2261220" cy="1042764"/>
           </a:xfrm>
           <a:prstGeom prst="rect">
@@ -4290,7 +4294,7 @@
         </p:nvCxnSpPr>
         <p:spPr>
           <a:xfrm flipH="1" flipV="1">
-            <a:off x="4034790" y="1920240"/>
+            <a:off x="5558790" y="1920240"/>
             <a:ext cx="216322" cy="548640"/>
           </a:xfrm>
           <a:prstGeom prst="line">
@@ -4317,37 +4321,6 @@
           </a:fontRef>
         </p:style>
       </p:cxnSp>
-      <p:sp>
-        <p:nvSpPr>
-          <p:cNvPr id="22" name="TextBox 21"/>
-          <p:cNvSpPr txBox="1"/>
-          <p:nvPr/>
-        </p:nvSpPr>
-        <p:spPr>
-          <a:xfrm>
-            <a:off x="640080" y="6217920"/>
-            <a:ext cx="7863840" cy="365760"/>
-          </a:xfrm>
-          <a:prstGeom prst="rect">
-            <a:avLst/>
-          </a:prstGeom>
-          <a:noFill/>
-        </p:spPr>
-        <p:txBody>
-          <a:bodyPr wrap="none">
-            <a:spAutoFit/>
-          </a:bodyPr>
-          <a:lstStyle/>
-          <a:p>
-            <a:pPr>
-              <a:defRPr sz="1200"/>
-            </a:pPr>
-            <a:r>
-              <a:t>Versión para profesor: simple, colores y formas variadas.</a:t>
-            </a:r>
-          </a:p>
-        </p:txBody>
-      </p:sp>
       <p:pic>
         <p:nvPicPr>
           <p:cNvPr id="79" name="Imagen 78">
@@ -4370,7 +4343,7 @@
         </p:blipFill>
         <p:spPr>
           <a:xfrm>
-            <a:off x="7152326" y="65722"/>
+            <a:off x="10203469" y="98732"/>
             <a:ext cx="1784240" cy="437198"/>
           </a:xfrm>
           <a:prstGeom prst="rect">

</xml_diff>